<commit_message>
add session 2 note in 1960
</commit_message>
<xml_diff>
--- a/26fall/1860/Lecture/Week1.2/Lecture 1.2.2.pptx
+++ b/26fall/1860/Lecture/Week1.2/Lecture 1.2.2.pptx
@@ -344,7 +344,7 @@
           <a:p>
             <a:fld id="{F0B0DD2E-599E-4F7E-9827-9783F8444458}" type="datetimeFigureOut">
               <a:rPr lang="en-GB" smtClean="0"/>
-              <a:t>26/03/2026</a:t>
+              <a:t>07/10/2026</a:t>
             </a:fld>
             <a:endParaRPr lang="en-GB"/>
           </a:p>
@@ -761,7 +761,7 @@
           <a:p>
             <a:fld id="{4F4D214D-53D4-4978-A5BF-E95A030A4F2C}" type="datetimeFigureOut">
               <a:rPr lang="en-GB" smtClean="0"/>
-              <a:t>26/03/2026</a:t>
+              <a:t>07/10/2026</a:t>
             </a:fld>
             <a:endParaRPr lang="en-GB"/>
           </a:p>
@@ -961,7 +961,7 @@
           <a:p>
             <a:fld id="{4F4D214D-53D4-4978-A5BF-E95A030A4F2C}" type="datetimeFigureOut">
               <a:rPr lang="en-GB" smtClean="0"/>
-              <a:t>26/03/2026</a:t>
+              <a:t>07/10/2026</a:t>
             </a:fld>
             <a:endParaRPr lang="en-GB"/>
           </a:p>
@@ -1171,7 +1171,7 @@
           <a:p>
             <a:fld id="{4F4D214D-53D4-4978-A5BF-E95A030A4F2C}" type="datetimeFigureOut">
               <a:rPr lang="en-GB" smtClean="0"/>
-              <a:t>26/03/2026</a:t>
+              <a:t>07/10/2026</a:t>
             </a:fld>
             <a:endParaRPr lang="en-GB"/>
           </a:p>
@@ -1371,7 +1371,7 @@
           <a:p>
             <a:fld id="{4F4D214D-53D4-4978-A5BF-E95A030A4F2C}" type="datetimeFigureOut">
               <a:rPr lang="en-GB" smtClean="0"/>
-              <a:t>26/03/2026</a:t>
+              <a:t>07/10/2026</a:t>
             </a:fld>
             <a:endParaRPr lang="en-GB"/>
           </a:p>
@@ -1647,7 +1647,7 @@
           <a:p>
             <a:fld id="{4F4D214D-53D4-4978-A5BF-E95A030A4F2C}" type="datetimeFigureOut">
               <a:rPr lang="en-GB" smtClean="0"/>
-              <a:t>26/03/2026</a:t>
+              <a:t>07/10/2026</a:t>
             </a:fld>
             <a:endParaRPr lang="en-GB"/>
           </a:p>
@@ -1915,7 +1915,7 @@
           <a:p>
             <a:fld id="{4F4D214D-53D4-4978-A5BF-E95A030A4F2C}" type="datetimeFigureOut">
               <a:rPr lang="en-GB" smtClean="0"/>
-              <a:t>26/03/2026</a:t>
+              <a:t>07/10/2026</a:t>
             </a:fld>
             <a:endParaRPr lang="en-GB"/>
           </a:p>
@@ -2330,7 +2330,7 @@
           <a:p>
             <a:fld id="{4F4D214D-53D4-4978-A5BF-E95A030A4F2C}" type="datetimeFigureOut">
               <a:rPr lang="en-GB" smtClean="0"/>
-              <a:t>26/03/2026</a:t>
+              <a:t>07/10/2026</a:t>
             </a:fld>
             <a:endParaRPr lang="en-GB"/>
           </a:p>
@@ -2472,7 +2472,7 @@
           <a:p>
             <a:fld id="{4F4D214D-53D4-4978-A5BF-E95A030A4F2C}" type="datetimeFigureOut">
               <a:rPr lang="en-GB" smtClean="0"/>
-              <a:t>26/03/2026</a:t>
+              <a:t>07/10/2026</a:t>
             </a:fld>
             <a:endParaRPr lang="en-GB"/>
           </a:p>
@@ -2585,7 +2585,7 @@
           <a:p>
             <a:fld id="{4F4D214D-53D4-4978-A5BF-E95A030A4F2C}" type="datetimeFigureOut">
               <a:rPr lang="en-GB" smtClean="0"/>
-              <a:t>26/03/2026</a:t>
+              <a:t>07/10/2026</a:t>
             </a:fld>
             <a:endParaRPr lang="en-GB"/>
           </a:p>
@@ -2898,7 +2898,7 @@
           <a:p>
             <a:fld id="{4F4D214D-53D4-4978-A5BF-E95A030A4F2C}" type="datetimeFigureOut">
               <a:rPr lang="en-GB" smtClean="0"/>
-              <a:t>26/03/2026</a:t>
+              <a:t>07/10/2026</a:t>
             </a:fld>
             <a:endParaRPr lang="en-GB"/>
           </a:p>
@@ -3187,7 +3187,7 @@
           <a:p>
             <a:fld id="{4F4D214D-53D4-4978-A5BF-E95A030A4F2C}" type="datetimeFigureOut">
               <a:rPr lang="en-GB" smtClean="0"/>
-              <a:t>26/03/2026</a:t>
+              <a:t>07/10/2026</a:t>
             </a:fld>
             <a:endParaRPr lang="en-GB"/>
           </a:p>
@@ -3439,7 +3439,7 @@
           <a:p>
             <a:fld id="{4F4D214D-53D4-4978-A5BF-E95A030A4F2C}" type="datetimeFigureOut">
               <a:rPr lang="en-GB" smtClean="0"/>
-              <a:t>26/03/2026</a:t>
+              <a:t>07/10/2026</a:t>
             </a:fld>
             <a:endParaRPr lang="en-GB"/>
           </a:p>
@@ -5146,15 +5146,7 @@
             <a:pPr lvl="1"/>
             <a:r>
               <a:rPr lang="en-GB" dirty="0"/>
-              <a:t>12345 </a:t>
-            </a:r>
-            <a:r>
-              <a:rPr lang="en-GB"/>
-              <a:t>= 123.45 </a:t>
-            </a:r>
-            <a:r>
-              <a:rPr lang="en-GB" dirty="0"/>
-              <a:t>× 100 = 1.2345 × 10</a:t>
+              <a:t>12345 = 123.45 × 100 = 1.2345 × 10</a:t>
             </a:r>
             <a:r>
               <a:rPr lang="en-GB" baseline="30000" dirty="0"/>
@@ -5178,8 +5170,21 @@
             </a:pPr>
             <a:r>
               <a:rPr lang="en-GB" dirty="0"/>
-              <a:t>Sign (+ in example)</a:t>
-            </a:r>
+              <a:t>Sign (+ in example)                                    </a:t>
+            </a:r>
+            <a:r>
+              <a:rPr lang="zh-CN" altLang="en-US" dirty="0">
+                <a:solidFill>
+                  <a:srgbClr val="FF0000"/>
+                </a:solidFill>
+              </a:rPr>
+              <a:t>尾数符号位</a:t>
+            </a:r>
+            <a:endParaRPr lang="en-GB" dirty="0">
+              <a:solidFill>
+                <a:srgbClr val="FF0000"/>
+              </a:solidFill>
+            </a:endParaRPr>
           </a:p>
           <a:p>
             <a:pPr marL="514350" indent="-514350">
@@ -5188,8 +5193,21 @@
             </a:pPr>
             <a:r>
               <a:rPr lang="en-GB" dirty="0"/>
-              <a:t>Mantissa (1.2345)</a:t>
-            </a:r>
+              <a:t>Mantissa (1.2345)                                     </a:t>
+            </a:r>
+            <a:r>
+              <a:rPr lang="zh-CN" altLang="en-US" dirty="0">
+                <a:solidFill>
+                  <a:srgbClr val="FF0000"/>
+                </a:solidFill>
+              </a:rPr>
+              <a:t>尾数：有效数字</a:t>
+            </a:r>
+            <a:endParaRPr lang="en-GB" dirty="0">
+              <a:solidFill>
+                <a:srgbClr val="FF0000"/>
+              </a:solidFill>
+            </a:endParaRPr>
           </a:p>
           <a:p>
             <a:pPr marL="514350" indent="-514350">
@@ -5206,8 +5224,21 @@
             </a:r>
             <a:r>
               <a:rPr lang="en-GB" dirty="0"/>
-              <a:t>)</a:t>
-            </a:r>
+              <a:t>)               </a:t>
+            </a:r>
+            <a:r>
+              <a:rPr lang="zh-CN" altLang="en-US" dirty="0">
+                <a:solidFill>
+                  <a:srgbClr val="FF0000"/>
+                </a:solidFill>
+              </a:rPr>
+              <a:t>指数符号位</a:t>
+            </a:r>
+            <a:endParaRPr lang="en-GB" dirty="0">
+              <a:solidFill>
+                <a:srgbClr val="FF0000"/>
+              </a:solidFill>
+            </a:endParaRPr>
           </a:p>
           <a:p>
             <a:pPr marL="514350" indent="-514350">
@@ -5224,8 +5255,45 @@
             </a:r>
             <a:r>
               <a:rPr lang="en-GB" dirty="0"/>
-              <a:t>)</a:t>
-            </a:r>
+              <a:t>)  </a:t>
+            </a:r>
+            <a:r>
+              <a:rPr lang="en-GB" dirty="0">
+                <a:solidFill>
+                  <a:srgbClr val="FF0000"/>
+                </a:solidFill>
+              </a:rPr>
+              <a:t> </a:t>
+            </a:r>
+            <a:r>
+              <a:rPr lang="zh-CN" altLang="en-US" dirty="0">
+                <a:solidFill>
+                  <a:srgbClr val="FF0000"/>
+                </a:solidFill>
+              </a:rPr>
+              <a:t>指数</a:t>
+            </a:r>
+            <a:r>
+              <a:rPr lang="en-US" altLang="zh-CN" dirty="0">
+                <a:solidFill>
+                  <a:srgbClr val="FF0000"/>
+                </a:solidFill>
+              </a:rPr>
+              <a:t>:    </a:t>
+            </a:r>
+            <a:r>
+              <a:rPr lang="zh-CN" altLang="en-US" dirty="0">
+                <a:solidFill>
+                  <a:srgbClr val="FF0000"/>
+                </a:solidFill>
+              </a:rPr>
+              <a:t>几次方</a:t>
+            </a:r>
+            <a:endParaRPr lang="en-GB" dirty="0">
+              <a:solidFill>
+                <a:srgbClr val="FF0000"/>
+              </a:solidFill>
+            </a:endParaRPr>
           </a:p>
           <a:p>
             <a:r>
@@ -5240,8 +5308,37 @@
             </a:pPr>
             <a:r>
               <a:rPr lang="en-GB" dirty="0"/>
-              <a:t>Base of the exponent (10)</a:t>
-            </a:r>
+              <a:t>Base of the exponent (10)                        </a:t>
+            </a:r>
+            <a:r>
+              <a:rPr lang="zh-CN" altLang="en-US" dirty="0">
+                <a:solidFill>
+                  <a:srgbClr val="FF0000"/>
+                </a:solidFill>
+              </a:rPr>
+              <a:t>指数以</a:t>
+            </a:r>
+            <a:r>
+              <a:rPr lang="en-US" altLang="zh-CN" dirty="0">
+                <a:solidFill>
+                  <a:srgbClr val="FF0000"/>
+                </a:solidFill>
+              </a:rPr>
+              <a:t>10</a:t>
+            </a:r>
+            <a:r>
+              <a:rPr lang="zh-CN" altLang="en-US" dirty="0">
+                <a:solidFill>
+                  <a:srgbClr val="FF0000"/>
+                </a:solidFill>
+              </a:rPr>
+              <a:t>为基</a:t>
+            </a:r>
+            <a:endParaRPr lang="en-GB" dirty="0">
+              <a:solidFill>
+                <a:srgbClr val="FF0000"/>
+              </a:solidFill>
+            </a:endParaRPr>
           </a:p>
           <a:p>
             <a:pPr marL="514350" indent="-514350">
@@ -7213,10 +7310,15 @@
             <p:ph idx="1"/>
           </p:nvPr>
         </p:nvSpPr>
-        <p:spPr/>
+        <p:spPr>
+          <a:xfrm>
+            <a:off x="838200" y="1825625"/>
+            <a:ext cx="11063514" cy="4667250"/>
+          </a:xfrm>
+        </p:spPr>
         <p:txBody>
           <a:bodyPr>
-            <a:normAutofit/>
+            <a:normAutofit lnSpcReduction="10000"/>
           </a:bodyPr>
           <a:lstStyle/>
           <a:p>
@@ -7269,7 +7371,31 @@
             <a:pPr lvl="1"/>
             <a:r>
               <a:rPr lang="en-GB" dirty="0"/>
-              <a:t>The next 8 bits represent the exponent, in </a:t>
+              <a:t>The next </a:t>
+            </a:r>
+            <a:r>
+              <a:rPr lang="en-GB" dirty="0">
+                <a:solidFill>
+                  <a:srgbClr val="FF0000"/>
+                </a:solidFill>
+              </a:rPr>
+              <a:t>8 bits </a:t>
+            </a:r>
+            <a:r>
+              <a:rPr lang="en-GB" dirty="0"/>
+              <a:t>represent the </a:t>
+            </a:r>
+            <a:r>
+              <a:rPr lang="en-GB" dirty="0">
+                <a:solidFill>
+                  <a:srgbClr val="FF0000"/>
+                </a:solidFill>
+              </a:rPr>
+              <a:t>exponent</a:t>
+            </a:r>
+            <a:r>
+              <a:rPr lang="en-GB" dirty="0"/>
+              <a:t>, in </a:t>
             </a:r>
             <a:r>
               <a:rPr lang="en-GB" dirty="0">
@@ -7284,8 +7410,36 @@
             <a:pPr lvl="1"/>
             <a:r>
               <a:rPr lang="en-GB" dirty="0"/>
-              <a:t>This leaves 23 bits for the mantissa.</a:t>
-            </a:r>
+              <a:t>This leaves </a:t>
+            </a:r>
+            <a:r>
+              <a:rPr lang="en-GB" dirty="0">
+                <a:solidFill>
+                  <a:srgbClr val="FF0000"/>
+                </a:solidFill>
+              </a:rPr>
+              <a:t>23 bits </a:t>
+            </a:r>
+            <a:r>
+              <a:rPr lang="en-GB" dirty="0"/>
+              <a:t>for the </a:t>
+            </a:r>
+            <a:r>
+              <a:rPr lang="en-GB" dirty="0">
+                <a:solidFill>
+                  <a:srgbClr val="FF0000"/>
+                </a:solidFill>
+              </a:rPr>
+              <a:t>mantissa</a:t>
+            </a:r>
+            <a:r>
+              <a:rPr lang="en-GB" dirty="0"/>
+              <a:t>.</a:t>
+            </a:r>
+          </a:p>
+          <a:p>
+            <a:pPr lvl="1"/>
+            <a:endParaRPr lang="en-GB" dirty="0"/>
           </a:p>
           <a:p>
             <a:r>
@@ -7306,14 +7460,78 @@
             </a:r>
             <a:r>
               <a:rPr lang="en-GB" dirty="0"/>
-              <a:t> with approximately 7 decimal digits of precision.</a:t>
-            </a:r>
-          </a:p>
-          <a:p>
-            <a:r>
-              <a:rPr lang="en-GB" dirty="0"/>
-              <a:t>This is the format specified in IEEE 754 for single precision floating-point numbers</a:t>
-            </a:r>
+              <a:t> with approximately 7 decimal digits of precision(</a:t>
+            </a:r>
+            <a:r>
+              <a:rPr lang="en-GB" dirty="0">
+                <a:solidFill>
+                  <a:srgbClr val="FF0000"/>
+                </a:solidFill>
+              </a:rPr>
+              <a:t>7</a:t>
+            </a:r>
+            <a:r>
+              <a:rPr lang="zh-CN" altLang="en-US" dirty="0">
+                <a:solidFill>
+                  <a:srgbClr val="FF0000"/>
+                </a:solidFill>
+              </a:rPr>
+              <a:t>位小数精度</a:t>
+            </a:r>
+            <a:r>
+              <a:rPr lang="en-US" altLang="zh-CN" dirty="0"/>
+              <a:t>)</a:t>
+            </a:r>
+            <a:r>
+              <a:rPr lang="en-GB" dirty="0"/>
+              <a:t>.</a:t>
+            </a:r>
+          </a:p>
+          <a:p>
+            <a:endParaRPr lang="en-GB" dirty="0"/>
+          </a:p>
+          <a:p>
+            <a:r>
+              <a:rPr lang="en-GB" dirty="0"/>
+              <a:t>This is the format specified in IEEE 754 </a:t>
+            </a:r>
+            <a:r>
+              <a:rPr lang="en-GB" dirty="0">
+                <a:solidFill>
+                  <a:srgbClr val="FF0000"/>
+                </a:solidFill>
+              </a:rPr>
+              <a:t>for single precision floating-point numbers</a:t>
+            </a:r>
+            <a:r>
+              <a:rPr lang="zh-CN" altLang="en-US" dirty="0">
+                <a:solidFill>
+                  <a:srgbClr val="FF0000"/>
+                </a:solidFill>
+              </a:rPr>
+              <a:t>（单精度浮点小数，对应数据类型</a:t>
+            </a:r>
+            <a:r>
+              <a:rPr lang="en-US" altLang="zh-CN" dirty="0">
+                <a:solidFill>
+                  <a:srgbClr val="FF0000"/>
+                </a:solidFill>
+              </a:rPr>
+              <a:t>: float</a:t>
+            </a:r>
+            <a:r>
+              <a:rPr lang="zh-CN" altLang="en-US" dirty="0">
+                <a:solidFill>
+                  <a:srgbClr val="FF0000"/>
+                </a:solidFill>
+              </a:rPr>
+              <a:t>）</a:t>
+            </a:r>
+            <a:endParaRPr lang="en-GB" dirty="0">
+              <a:solidFill>
+                <a:srgbClr val="FF0000"/>
+              </a:solidFill>
+            </a:endParaRPr>
           </a:p>
           <a:p>
             <a:pPr lvl="1"/>
@@ -8749,7 +8967,12 @@
             <p:ph type="title"/>
           </p:nvPr>
         </p:nvSpPr>
-        <p:spPr/>
+        <p:spPr>
+          <a:xfrm>
+            <a:off x="776514" y="278039"/>
+            <a:ext cx="10515600" cy="1325563"/>
+          </a:xfrm>
+        </p:spPr>
         <p:txBody>
           <a:bodyPr/>
           <a:lstStyle/>
@@ -9742,6 +9965,25 @@
           </a:p>
           <a:p>
             <a:r>
+              <a:rPr lang="en-US" altLang="zh-CN" sz="2400" dirty="0">
+                <a:solidFill>
+                  <a:schemeClr val="accent6">
+                    <a:lumMod val="75000"/>
+                  </a:schemeClr>
+                </a:solidFill>
+              </a:rPr>
+              <a:t>Bias 15</a:t>
+            </a:r>
+            <a:endParaRPr lang="en-GB" sz="2400" dirty="0">
+              <a:solidFill>
+                <a:schemeClr val="accent6">
+                  <a:lumMod val="75000"/>
+                </a:schemeClr>
+              </a:solidFill>
+            </a:endParaRPr>
+          </a:p>
+          <a:p>
+            <a:r>
               <a:rPr lang="en-GB" dirty="0"/>
               <a:t>Next 5 bits used for exponent</a:t>
             </a:r>
@@ -9766,11 +10008,30 @@
               <a:rPr lang="en-GB" dirty="0"/>
               <a:t>11110 (30)is +15 (max exponent)</a:t>
             </a:r>
+          </a:p>
+          <a:p>
+            <a:pPr marL="457200" lvl="1" indent="0">
+              <a:buNone/>
+            </a:pPr>
+            <a:r>
+              <a:rPr lang="en-GB" altLang="zh-CN" dirty="0"/>
+              <a:t>Next 5 bits used for exponent</a:t>
+            </a:r>
+          </a:p>
+          <a:p>
+            <a:pPr lvl="1"/>
+            <a:endParaRPr lang="en-GB" dirty="0"/>
+          </a:p>
+          <a:p>
+            <a:pPr marL="457200" lvl="1" indent="0">
+              <a:buNone/>
+            </a:pPr>
+            <a:endParaRPr lang="en-GB" dirty="0"/>
           </a:p>
         </p:txBody>
       </p:sp>
-      <mc:AlternateContent xmlns:mc="http://schemas.openxmlformats.org/markup-compatibility/2006" xmlns:a14="http://schemas.microsoft.com/office/drawing/2010/main">
-        <mc:Choice Requires="a14">
+      <mc:AlternateContent xmlns:mc="http://schemas.openxmlformats.org/markup-compatibility/2006">
+        <mc:Choice xmlns:a14="http://schemas.microsoft.com/office/drawing/2010/main" Requires="a14">
           <p:sp>
             <p:nvSpPr>
               <p:cNvPr id="4" name="Content Placeholder 3">
@@ -9976,7 +10237,7 @@
             </p:txBody>
           </p:sp>
         </mc:Choice>
-        <mc:Fallback xmlns="">
+        <mc:Fallback>
           <p:sp>
             <p:nvSpPr>
               <p:cNvPr id="4" name="Content Placeholder 3">
@@ -10006,7 +10267,7 @@
               <a:lstStyle/>
               <a:p>
                 <a:r>
-                  <a:rPr lang="en-GB">
+                  <a:rPr lang="zh-CN" altLang="en-US">
                     <a:noFill/>
                   </a:rPr>
                   <a:t> </a:t>

</xml_diff>